<commit_message>
Update Day 1 material for the new project Makefile
Master added a full Makefile (setup/dev/quality/docker/frontend/clean targets).
Reframe Day 1 Block 5 from "create a Makefile from scratch" to "read, understand
and extend the real one": anatomy (SHELL/.SHELLFLAGS, .DEFAULT_GOAL, self-documented
help), target sections, check = lint+typecheck+test as local CI, test-unit/-integration
markers, and a db-shell hands-on. Sync README, apostila (HTML + PDF) and the slide deck.

Co-Authored-By: Claude Opus 4.8 <noreply@anthropic.com>
Claude-Session: https://claude.ai/code/session_0138ka97tvHfnh9A6KG3zR6j
</commit_message>
<xml_diff>
--- a/docs/workshop/ScreenFlix-Workshop.pptx
+++ b/docs/workshop/ScreenFlix-Workshop.pptx
@@ -19300,7 +19300,7 @@
                 </a:solidFill>
                 <a:latin typeface="Consolas"/>
               </a:rPr>
-              <a:t># Com Makefile vira:</a:t>
+              <a:t># O projeto tem Makefile:</a:t>
             </a:r>
           </a:p>
           <a:p>
@@ -19319,7 +19319,7 @@
                 </a:solidFill>
                 <a:latin typeface="Consolas"/>
               </a:rPr>
-              <a:t>make up      make check</a:t>
+              <a:t>make dev       make up-build</a:t>
             </a:r>
           </a:p>
           <a:p>
@@ -19338,7 +19338,7 @@
                 </a:solidFill>
                 <a:latin typeface="Consolas"/>
               </a:rPr>
-              <a:t>make dev     make build</a:t>
+              <a:t>make check     make front-dev</a:t>
             </a:r>
           </a:p>
         </p:txBody>
@@ -19416,7 +19416,7 @@
                 </a:solidFill>
                 <a:latin typeface="Arial"/>
               </a:rPr>
-              <a:t>Ninguém decora o comando longo do</a:t>
+              <a:t>Já existe no repo. Ninguém decora o</a:t>
             </a:r>
           </a:p>
           <a:p>
@@ -19435,7 +19435,7 @@
                 </a:solidFill>
                 <a:latin typeface="Arial"/>
               </a:rPr>
-              <a:t>uvicorn. Com Makefile vira make dev.</a:t>
+              <a:t>comando longo do uvicorn → make dev.</a:t>
             </a:r>
           </a:p>
           <a:p>
@@ -19473,7 +19473,7 @@
                 </a:solidFill>
                 <a:latin typeface="Arial"/>
               </a:rPr>
-              <a:t>• make help → documentação executável</a:t>
+              <a:t>• .DEFAULT_GOAL=help (self-documented)</a:t>
             </a:r>
           </a:p>
           <a:p>
@@ -19492,7 +19492,7 @@
                 </a:solidFill>
                 <a:latin typeface="Arial"/>
               </a:rPr>
-              <a:t>• make check → roda os quality gates</a:t>
+              <a:t>• Seções: setup · dev · qualidade ·</a:t>
             </a:r>
           </a:p>
           <a:p>
@@ -19511,7 +19511,7 @@
                 </a:solidFill>
                 <a:latin typeface="Arial"/>
               </a:rPr>
-              <a:t>  (ruff format, ruff check, mypy, pytest)</a:t>
+              <a:t>  docker · frontend · limpeza</a:t>
             </a:r>
           </a:p>
           <a:p>
@@ -19530,6 +19530,44 @@
                 </a:solidFill>
                 <a:latin typeface="Arial"/>
               </a:rPr>
+              <a:t>• make check = CI local (lint+types+test)</a:t>
+            </a:r>
+          </a:p>
+          <a:p>
+            <a:pPr>
+              <a:lnSpc>
+                <a:spcPct val="105000"/>
+              </a:lnSpc>
+              <a:spcAft>
+                <a:spcPts val="300"/>
+              </a:spcAft>
+            </a:pPr>
+            <a:r>
+              <a:rPr sz="1300">
+                <a:solidFill>
+                  <a:srgbClr val="A9B0BD"/>
+                </a:solidFill>
+                <a:latin typeface="Arial"/>
+              </a:rPr>
+              <a:t>• test-unit / test-integration (markers)</a:t>
+            </a:r>
+          </a:p>
+          <a:p>
+            <a:pPr>
+              <a:lnSpc>
+                <a:spcPct val="105000"/>
+              </a:lnSpc>
+              <a:spcAft>
+                <a:spcPts val="300"/>
+              </a:spcAft>
+            </a:pPr>
+            <a:r>
+              <a:rPr sz="1300">
+                <a:solidFill>
+                  <a:srgbClr val="A9B0BD"/>
+                </a:solidFill>
+                <a:latin typeface="Arial"/>
+              </a:rPr>
               <a:t/>
             </a:r>
           </a:p>
@@ -19549,26 +19587,7 @@
                 </a:solidFill>
                 <a:latin typeface="Arial"/>
               </a:rPr>
-              <a:t>⚠ NÃO existe ainda no repo:</a:t>
-            </a:r>
-          </a:p>
-          <a:p>
-            <a:pPr>
-              <a:lnSpc>
-                <a:spcPct val="105000"/>
-              </a:lnSpc>
-              <a:spcAft>
-                <a:spcPts val="300"/>
-              </a:spcAft>
-            </a:pPr>
-            <a:r>
-              <a:rPr sz="1300">
-                <a:solidFill>
-                  <a:srgbClr val="A9B0BD"/>
-                </a:solidFill>
-                <a:latin typeface="Arial"/>
-              </a:rPr>
-              <a:t>   criá-lo é o hands-on do dia.</a:t>
+              <a:t>Hands-on: estender com make db-shell.</a:t>
             </a:r>
           </a:p>
         </p:txBody>

</xml_diff>